<commit_message>
Add Day 02: Filtering & Aggregation
Migrates the old SQL 02/ layout onto the D0N_0M_Category + day0N_
convention established in Day 01: D02_01_Materials (DB setup, schema
reference, dates_specifiers.jpg, new day02_reading.md, and a 16-slide
.pptx deck), D02_02_Walkthrough, D02_03_Exercises.

The reading doc and deck cover WHERE, AND/OR, BETWEEN, IN vs OR, NULL,
LIKE, GROUP BY, and DATE functions, with a Mermaid ERD for the
region->sales_reps->accounts->{orders,web_events} chain and a GROUP BY
bucketing visual. Adds chain_fork_slide and group_by_diagram_slide to
_slide_kit/deckkit.py, plus a header-overlap fix for long two-line
titles (Day 01's deck rebuilt with the same fix).

Dropped the unused SQL Server (T-SQL) variant of the database script —
this course is MySQL-only.

Co-Authored-By: Claude Sonnet 5 <noreply@anthropic.com>
</commit_message>
<xml_diff>
--- a/Day 01/D01_01_Materials/Day 01 - SQL Foundations.pptx
+++ b/Day 01/D01_01_Materials/Day 01 - SQL Foundations.pptx
@@ -3395,7 +3395,7 @@
         <p:spPr>
           <a:xfrm>
             <a:off x="548640" y="777240"/>
-            <a:ext cx="10515600" cy="1005840"/>
+            <a:ext cx="10515600" cy="704088"/>
           </a:xfrm>
           <a:prstGeom prst="rect">
             <a:avLst/>
@@ -3428,7 +3428,7 @@
         </p:nvSpPr>
         <p:spPr>
           <a:xfrm>
-            <a:off x="548640" y="1600200"/>
+            <a:off x="548640" y="1481328"/>
             <a:ext cx="10515600" cy="457200"/>
           </a:xfrm>
           <a:prstGeom prst="rect">
@@ -4391,7 +4391,7 @@
         <p:spPr>
           <a:xfrm>
             <a:off x="548640" y="777240"/>
-            <a:ext cx="10515600" cy="1005840"/>
+            <a:ext cx="10515600" cy="704088"/>
           </a:xfrm>
           <a:prstGeom prst="rect">
             <a:avLst/>
@@ -4424,7 +4424,7 @@
         </p:nvSpPr>
         <p:spPr>
           <a:xfrm>
-            <a:off x="548640" y="1600200"/>
+            <a:off x="548640" y="1481328"/>
             <a:ext cx="10515600" cy="457200"/>
           </a:xfrm>
           <a:prstGeom prst="rect">
@@ -5089,7 +5089,7 @@
         <p:spPr>
           <a:xfrm>
             <a:off x="548640" y="777240"/>
-            <a:ext cx="10515600" cy="1005840"/>
+            <a:ext cx="10515600" cy="704088"/>
           </a:xfrm>
           <a:prstGeom prst="rect">
             <a:avLst/>
@@ -5122,7 +5122,7 @@
         </p:nvSpPr>
         <p:spPr>
           <a:xfrm>
-            <a:off x="548640" y="1600200"/>
+            <a:off x="548640" y="1481328"/>
             <a:ext cx="10515600" cy="457200"/>
           </a:xfrm>
           <a:prstGeom prst="rect">
@@ -5997,7 +5997,7 @@
         <p:spPr>
           <a:xfrm>
             <a:off x="548640" y="777240"/>
-            <a:ext cx="10515600" cy="1005840"/>
+            <a:ext cx="10515600" cy="704088"/>
           </a:xfrm>
           <a:prstGeom prst="rect">
             <a:avLst/>
@@ -6030,7 +6030,7 @@
         </p:nvSpPr>
         <p:spPr>
           <a:xfrm>
-            <a:off x="548640" y="1600200"/>
+            <a:off x="548640" y="1481328"/>
             <a:ext cx="10515600" cy="457200"/>
           </a:xfrm>
           <a:prstGeom prst="rect">
@@ -6780,7 +6780,7 @@
         <p:spPr>
           <a:xfrm>
             <a:off x="548640" y="777240"/>
-            <a:ext cx="10515600" cy="1005840"/>
+            <a:ext cx="10515600" cy="704088"/>
           </a:xfrm>
           <a:prstGeom prst="rect">
             <a:avLst/>
@@ -6813,7 +6813,7 @@
         </p:nvSpPr>
         <p:spPr>
           <a:xfrm>
-            <a:off x="548640" y="1600200"/>
+            <a:off x="548640" y="1481328"/>
             <a:ext cx="10515600" cy="457200"/>
           </a:xfrm>
           <a:prstGeom prst="rect">
@@ -7785,7 +7785,7 @@
         <p:spPr>
           <a:xfrm>
             <a:off x="548640" y="777240"/>
-            <a:ext cx="10515600" cy="1005840"/>
+            <a:ext cx="10515600" cy="704088"/>
           </a:xfrm>
           <a:prstGeom prst="rect">
             <a:avLst/>
@@ -7818,7 +7818,7 @@
         </p:nvSpPr>
         <p:spPr>
           <a:xfrm>
-            <a:off x="548640" y="1600200"/>
+            <a:off x="548640" y="1481328"/>
             <a:ext cx="10515600" cy="457200"/>
           </a:xfrm>
           <a:prstGeom prst="rect">
@@ -8715,7 +8715,7 @@
         <p:spPr>
           <a:xfrm>
             <a:off x="548640" y="777240"/>
-            <a:ext cx="10515600" cy="1005840"/>
+            <a:ext cx="10515600" cy="704088"/>
           </a:xfrm>
           <a:prstGeom prst="rect">
             <a:avLst/>
@@ -8748,7 +8748,7 @@
         </p:nvSpPr>
         <p:spPr>
           <a:xfrm>
-            <a:off x="548640" y="1600200"/>
+            <a:off x="548640" y="1481328"/>
             <a:ext cx="10515600" cy="457200"/>
           </a:xfrm>
           <a:prstGeom prst="rect">
@@ -9428,7 +9428,7 @@
         <p:spPr>
           <a:xfrm>
             <a:off x="548640" y="777240"/>
-            <a:ext cx="10515600" cy="1005840"/>
+            <a:ext cx="10515600" cy="704088"/>
           </a:xfrm>
           <a:prstGeom prst="rect">
             <a:avLst/>
@@ -9461,7 +9461,7 @@
         </p:nvSpPr>
         <p:spPr>
           <a:xfrm>
-            <a:off x="548640" y="1600200"/>
+            <a:off x="548640" y="1481328"/>
             <a:ext cx="10515600" cy="457200"/>
           </a:xfrm>
           <a:prstGeom prst="rect">
@@ -10473,7 +10473,7 @@
         <p:spPr>
           <a:xfrm>
             <a:off x="548640" y="777240"/>
-            <a:ext cx="10515600" cy="1005840"/>
+            <a:ext cx="10515600" cy="704088"/>
           </a:xfrm>
           <a:prstGeom prst="rect">
             <a:avLst/>
@@ -10506,7 +10506,7 @@
         </p:nvSpPr>
         <p:spPr>
           <a:xfrm>
-            <a:off x="548640" y="1600200"/>
+            <a:off x="548640" y="1481328"/>
             <a:ext cx="10515600" cy="457200"/>
           </a:xfrm>
           <a:prstGeom prst="rect">
@@ -11640,7 +11640,7 @@
         <p:spPr>
           <a:xfrm>
             <a:off x="548640" y="777240"/>
-            <a:ext cx="10515600" cy="1005840"/>
+            <a:ext cx="10515600" cy="704088"/>
           </a:xfrm>
           <a:prstGeom prst="rect">
             <a:avLst/>
@@ -11673,7 +11673,7 @@
         </p:nvSpPr>
         <p:spPr>
           <a:xfrm>
-            <a:off x="548640" y="1600200"/>
+            <a:off x="548640" y="1481328"/>
             <a:ext cx="10515600" cy="457200"/>
           </a:xfrm>
           <a:prstGeom prst="rect">
@@ -12970,7 +12970,7 @@
         <p:spPr>
           <a:xfrm>
             <a:off x="548640" y="777240"/>
-            <a:ext cx="10515600" cy="1005840"/>
+            <a:ext cx="10515600" cy="704088"/>
           </a:xfrm>
           <a:prstGeom prst="rect">
             <a:avLst/>
@@ -13003,7 +13003,7 @@
         </p:nvSpPr>
         <p:spPr>
           <a:xfrm>
-            <a:off x="548640" y="1600200"/>
+            <a:off x="548640" y="1481328"/>
             <a:ext cx="10515600" cy="457200"/>
           </a:xfrm>
           <a:prstGeom prst="rect">
@@ -13517,7 +13517,7 @@
         <p:spPr>
           <a:xfrm>
             <a:off x="548640" y="777240"/>
-            <a:ext cx="10515600" cy="1005840"/>
+            <a:ext cx="10515600" cy="704088"/>
           </a:xfrm>
           <a:prstGeom prst="rect">
             <a:avLst/>
@@ -13550,7 +13550,7 @@
         </p:nvSpPr>
         <p:spPr>
           <a:xfrm>
-            <a:off x="548640" y="1600200"/>
+            <a:off x="548640" y="1481328"/>
             <a:ext cx="10515600" cy="457200"/>
           </a:xfrm>
           <a:prstGeom prst="rect">
@@ -14180,7 +14180,7 @@
         <p:spPr>
           <a:xfrm>
             <a:off x="548640" y="777240"/>
-            <a:ext cx="10515600" cy="1005840"/>
+            <a:ext cx="10515600" cy="704088"/>
           </a:xfrm>
           <a:prstGeom prst="rect">
             <a:avLst/>
@@ -15422,7 +15422,7 @@
         <p:spPr>
           <a:xfrm>
             <a:off x="548640" y="777240"/>
-            <a:ext cx="10515600" cy="1005840"/>
+            <a:ext cx="10515600" cy="704088"/>
           </a:xfrm>
           <a:prstGeom prst="rect">
             <a:avLst/>
@@ -15455,7 +15455,7 @@
         </p:nvSpPr>
         <p:spPr>
           <a:xfrm>
-            <a:off x="548640" y="1600200"/>
+            <a:off x="548640" y="1481328"/>
             <a:ext cx="10515600" cy="457200"/>
           </a:xfrm>
           <a:prstGeom prst="rect">
@@ -16383,7 +16383,7 @@
         <p:spPr>
           <a:xfrm>
             <a:off x="548640" y="777240"/>
-            <a:ext cx="10515600" cy="1005840"/>
+            <a:ext cx="10515600" cy="704088"/>
           </a:xfrm>
           <a:prstGeom prst="rect">
             <a:avLst/>
@@ -16416,7 +16416,7 @@
         </p:nvSpPr>
         <p:spPr>
           <a:xfrm>
-            <a:off x="548640" y="1600200"/>
+            <a:off x="548640" y="1481328"/>
             <a:ext cx="10515600" cy="457200"/>
           </a:xfrm>
           <a:prstGeom prst="rect">
@@ -18228,7 +18228,7 @@
         <p:spPr>
           <a:xfrm>
             <a:off x="548640" y="777240"/>
-            <a:ext cx="10515600" cy="1005840"/>
+            <a:ext cx="10515600" cy="704088"/>
           </a:xfrm>
           <a:prstGeom prst="rect">
             <a:avLst/>
@@ -18261,7 +18261,7 @@
         </p:nvSpPr>
         <p:spPr>
           <a:xfrm>
-            <a:off x="548640" y="1600200"/>
+            <a:off x="548640" y="1481328"/>
             <a:ext cx="10515600" cy="457200"/>
           </a:xfrm>
           <a:prstGeom prst="rect">
@@ -18927,7 +18927,7 @@
         <p:spPr>
           <a:xfrm>
             <a:off x="548640" y="777240"/>
-            <a:ext cx="10515600" cy="1005840"/>
+            <a:ext cx="10515600" cy="704088"/>
           </a:xfrm>
           <a:prstGeom prst="rect">
             <a:avLst/>
@@ -18960,7 +18960,7 @@
         </p:nvSpPr>
         <p:spPr>
           <a:xfrm>
-            <a:off x="548640" y="1600200"/>
+            <a:off x="548640" y="1481328"/>
             <a:ext cx="10515600" cy="457200"/>
           </a:xfrm>
           <a:prstGeom prst="rect">

</xml_diff>